<commit_message>
TemaFinale26 17/06: Sprint 3 - slides (EN) aggiornate a 28 PASS
</commit_message>
<xml_diff>
--- a/TemaFinale26/Sprint3/userDocs/slides/TemaFinale26_slides.pptx
+++ b/TemaFinale26/Sprint3/userDocs/slides/TemaFinale26_slides.pptx
@@ -5003,7 +5003,7 @@
                 <a:ea typeface="Calibri" pitchFamily="34" charset="-122"/>
                 <a:cs typeface="Calibri" pitchFamily="34" charset="-120"/>
               </a:rPr>
-              <a:t>Sprint3_v1 + final system (24 PASS) + slides</a:t>
+              <a:t>Sprint3_v1 + final system (28 PASS) + slides</a:t>
             </a:r>
             <a:endParaRPr lang="en-US" sz="1050" dirty="0"/>
           </a:p>
@@ -10038,7 +10038,7 @@
                 <a:ea typeface="Calibri" pitchFamily="34" charset="-122"/>
                 <a:cs typeface="Calibri" pitchFamily="34" charset="-120"/>
               </a:rPr>
-              <a:t>Unit: TestHold 24 PASS, 0 FAIL  |  build: SUCCESS</a:t>
+              <a:t>Unit: TestHold 28 PASS, 0 FAIL  |  build: SUCCESS</a:t>
             </a:r>
             <a:endParaRPr lang="en-US" sz="1150" dirty="0"/>
           </a:p>
@@ -11122,7 +11122,7 @@
                 <a:ea typeface="Calibri" pitchFamily="34" charset="-122"/>
                 <a:cs typeface="Calibri" pitchFamily="34" charset="-120"/>
               </a:rPr>
-              <a:t>TestHold 16/20/24 PASS; end-to-end demo; automated TP1 with the tester actor</a:t>
+              <a:t>TestHold 16/20/28 PASS; end-to-end demo; automated TP1 with the tester actor</a:t>
             </a:r>
             <a:endParaRPr lang="en-US" sz="1400" dirty="0"/>
           </a:p>

</xml_diff>

<commit_message>
TemaFinale26 17/06: Sprint 3 - correzione posizioni slot sulla mappa del committente (slot3=(3,1) slot4=(3,4) slot5=(2,5)); doc/slides/README aggiornati
</commit_message>
<xml_diff>
--- a/TemaFinale26/Sprint3/userDocs/slides/TemaFinale26_slides.pptx
+++ b/TemaFinale26/Sprint3/userDocs/slides/TemaFinale26_slides.pptx
@@ -3632,7 +3632,7 @@
         </p:nvSpPr>
         <p:spPr>
           <a:xfrm>
-            <a:off x="7461504" y="1261872"/>
+            <a:off x="5559552" y="3163824"/>
             <a:ext cx="420624" cy="420624"/>
           </a:xfrm>
           <a:prstGeom prst="rect">
@@ -3652,7 +3652,7 @@
         </p:nvSpPr>
         <p:spPr>
           <a:xfrm>
-            <a:off x="7434072" y="1234440"/>
+            <a:off x="5532120" y="3136392"/>
             <a:ext cx="475488" cy="475488"/>
           </a:xfrm>
           <a:prstGeom prst="rect">
@@ -3750,7 +3750,7 @@
         </p:nvSpPr>
         <p:spPr>
           <a:xfrm>
-            <a:off x="6035040" y="3163824"/>
+            <a:off x="7461504" y="1737360"/>
             <a:ext cx="420624" cy="420624"/>
           </a:xfrm>
           <a:prstGeom prst="rect">
@@ -3770,7 +3770,7 @@
         </p:nvSpPr>
         <p:spPr>
           <a:xfrm>
-            <a:off x="6007608" y="3136392"/>
+            <a:off x="7434072" y="1709928"/>
             <a:ext cx="475488" cy="475488"/>
           </a:xfrm>
           <a:prstGeom prst="rect">
@@ -3809,7 +3809,7 @@
         </p:nvSpPr>
         <p:spPr>
           <a:xfrm>
-            <a:off x="7461504" y="2688336"/>
+            <a:off x="6035040" y="2688336"/>
             <a:ext cx="420624" cy="420624"/>
           </a:xfrm>
           <a:prstGeom prst="rect">
@@ -3829,7 +3829,7 @@
         </p:nvSpPr>
         <p:spPr>
           <a:xfrm>
-            <a:off x="7434072" y="2660904"/>
+            <a:off x="6007608" y="2660904"/>
             <a:ext cx="475488" cy="475488"/>
           </a:xfrm>
           <a:prstGeom prst="rect">
@@ -3868,7 +3868,7 @@
         </p:nvSpPr>
         <p:spPr>
           <a:xfrm>
-            <a:off x="7461504" y="2212848"/>
+            <a:off x="7461504" y="2688336"/>
             <a:ext cx="420624" cy="420624"/>
           </a:xfrm>
           <a:prstGeom prst="rect">
@@ -3888,7 +3888,7 @@
         </p:nvSpPr>
         <p:spPr>
           <a:xfrm>
-            <a:off x="7434072" y="2185416"/>
+            <a:off x="7434072" y="2660904"/>
             <a:ext cx="475488" cy="475488"/>
           </a:xfrm>
           <a:prstGeom prst="rect">
@@ -3927,7 +3927,7 @@
         </p:nvSpPr>
         <p:spPr>
           <a:xfrm>
-            <a:off x="6986016" y="3163824"/>
+            <a:off x="7936992" y="2212848"/>
             <a:ext cx="420624" cy="420624"/>
           </a:xfrm>
           <a:prstGeom prst="rect">
@@ -3947,7 +3947,7 @@
         </p:nvSpPr>
         <p:spPr>
           <a:xfrm>
-            <a:off x="6958584" y="3136392"/>
+            <a:off x="7909560" y="2185416"/>
             <a:ext cx="475488" cy="475488"/>
           </a:xfrm>
           <a:prstGeom prst="rect">
@@ -4011,7 +4011,7 @@
                 <a:ea typeface="Calibri" pitchFamily="34" charset="-122"/>
                 <a:cs typeface="Calibri" pitchFamily="34" charset="-120"/>
               </a:rPr>
-              <a:t>S5 = marking area (marker)   |   S1..S4 = load slots (reachable cells)</a:t>
+              <a:t>positions from the customer's map  |  S1..S4 = load slots, S5 = marking area</a:t>
             </a:r>
             <a:endParaRPr lang="en-US" sz="1000" dirty="0"/>
           </a:p>
@@ -11178,7 +11178,7 @@
                 <a:ea typeface="Calibri" pitchFamily="34" charset="-122"/>
                 <a:cs typeface="Calibri" pitchFamily="34" charset="-120"/>
               </a:rPr>
-              <a:t>on the DDR map (tf25map), slot3=(3,2) and slot4=(5,3) fell on obstacle cells -&gt; A* returned an empty plan. Corrected to reachable cells (slot3-&gt;(4,3), slot4-&gt;(4,2)). Open points to confirm with the customer: DFREE &amp; the 3s window; the slot positions; the Out-of-service recovery policy; the real PicoW in place of the web-gui.</a:t>
+              <a:t>the provisional slot3=(3,2)/slot4=(5,3) fell on obstacle cells of the DDR map (tf25map) -&gt; A* returned an empty plan (the robot went to the wrong place). Positions confirmed on the customer's map: slot1=(1,1) slot2=(1,4) slot3=(3,1) slot4=(3,4) (load), slot5=(2,5) (marking). Open points to confirm: DFREE &amp; the 3s window; the Out-of-service recovery policy; the real PicoW in place of the web-gui.</a:t>
             </a:r>
             <a:endParaRPr lang="en-US" sz="1100" dirty="0"/>
           </a:p>

</xml_diff>

<commit_message>
TemaFinale26 18/06: Sprint 3 - mappa fedele a tf25map nelle slide (colonna 6 di transito libera dopo lo slot5, muri/ostacoli); TestHold 29 PASS allineato in doc/slide/README
</commit_message>
<xml_diff>
--- a/TemaFinale26/Sprint3/userDocs/slides/TemaFinale26_slides.pptx
+++ b/TemaFinale26/Sprint3/userDocs/slides/TemaFinale26_slides.pptx
@@ -2784,8 +2784,8 @@
         </p:nvSpPr>
         <p:spPr>
           <a:xfrm>
-            <a:off x="5440680" y="960120"/>
-            <a:ext cx="3566160" cy="228600"/>
+            <a:off x="5349240" y="923544"/>
+            <a:ext cx="3456432" cy="219456"/>
           </a:xfrm>
           <a:prstGeom prst="rect">
             <a:avLst/>
@@ -2801,7 +2801,7 @@
               <a:buNone/>
             </a:pPr>
             <a:r>
-              <a:rPr lang="en-US" sz="1050" i="1" dirty="0">
+              <a:rPr lang="en-US" sz="1000" i="1" dirty="0">
                 <a:solidFill>
                   <a:srgbClr val="5A6B7B"/>
                 </a:solidFill>
@@ -2809,9 +2809,9 @@
                 <a:ea typeface="Calibri" pitchFamily="34" charset="-122"/>
                 <a:cs typeface="Calibri" pitchFamily="34" charset="-120"/>
               </a:rPr>
-              <a:t>The hold as a grid (X,Y) - positions from the DDR map</a:t>
-            </a:r>
-            <a:endParaRPr lang="en-US" sz="1050" dirty="0"/>
+              <a:t>The hold = the DDR map  (X = row, Y = col)</a:t>
+            </a:r>
+            <a:endParaRPr lang="en-US" sz="1000" dirty="0"/>
           </a:p>
         </p:txBody>
       </p:sp>
@@ -2823,8 +2823,8 @@
         </p:nvSpPr>
         <p:spPr>
           <a:xfrm>
-            <a:off x="5532120" y="1234440"/>
-            <a:ext cx="475488" cy="475488"/>
+            <a:off x="5394960" y="1170432"/>
+            <a:ext cx="420624" cy="420624"/>
           </a:xfrm>
           <a:prstGeom prst="rect">
             <a:avLst/>
@@ -2832,7 +2832,7 @@
           <a:solidFill>
             <a:srgbClr val="F6FAFE"/>
           </a:solidFill>
-          <a:ln w="12700">
+          <a:ln w="9525">
             <a:solidFill>
               <a:srgbClr val="CADCFC"/>
             </a:solidFill>
@@ -2848,8 +2848,8 @@
         </p:nvSpPr>
         <p:spPr>
           <a:xfrm>
-            <a:off x="6007608" y="1234440"/>
-            <a:ext cx="475488" cy="475488"/>
+            <a:off x="5815584" y="1170432"/>
+            <a:ext cx="420624" cy="420624"/>
           </a:xfrm>
           <a:prstGeom prst="rect">
             <a:avLst/>
@@ -2857,7 +2857,7 @@
           <a:solidFill>
             <a:srgbClr val="F6FAFE"/>
           </a:solidFill>
-          <a:ln w="12700">
+          <a:ln w="9525">
             <a:solidFill>
               <a:srgbClr val="CADCFC"/>
             </a:solidFill>
@@ -2873,8 +2873,8 @@
         </p:nvSpPr>
         <p:spPr>
           <a:xfrm>
-            <a:off x="6483096" y="1234440"/>
-            <a:ext cx="475488" cy="475488"/>
+            <a:off x="6236208" y="1170432"/>
+            <a:ext cx="420624" cy="420624"/>
           </a:xfrm>
           <a:prstGeom prst="rect">
             <a:avLst/>
@@ -2882,7 +2882,7 @@
           <a:solidFill>
             <a:srgbClr val="F6FAFE"/>
           </a:solidFill>
-          <a:ln w="12700">
+          <a:ln w="9525">
             <a:solidFill>
               <a:srgbClr val="CADCFC"/>
             </a:solidFill>
@@ -2898,8 +2898,8 @@
         </p:nvSpPr>
         <p:spPr>
           <a:xfrm>
-            <a:off x="6958584" y="1234440"/>
-            <a:ext cx="475488" cy="475488"/>
+            <a:off x="6656832" y="1170432"/>
+            <a:ext cx="420624" cy="420624"/>
           </a:xfrm>
           <a:prstGeom prst="rect">
             <a:avLst/>
@@ -2907,7 +2907,7 @@
           <a:solidFill>
             <a:srgbClr val="F6FAFE"/>
           </a:solidFill>
-          <a:ln w="12700">
+          <a:ln w="9525">
             <a:solidFill>
               <a:srgbClr val="CADCFC"/>
             </a:solidFill>
@@ -2923,8 +2923,8 @@
         </p:nvSpPr>
         <p:spPr>
           <a:xfrm>
-            <a:off x="7434072" y="1234440"/>
-            <a:ext cx="475488" cy="475488"/>
+            <a:off x="7077456" y="1170432"/>
+            <a:ext cx="420624" cy="420624"/>
           </a:xfrm>
           <a:prstGeom prst="rect">
             <a:avLst/>
@@ -2932,7 +2932,7 @@
           <a:solidFill>
             <a:srgbClr val="F6FAFE"/>
           </a:solidFill>
-          <a:ln w="12700">
+          <a:ln w="9525">
             <a:solidFill>
               <a:srgbClr val="CADCFC"/>
             </a:solidFill>
@@ -2948,8 +2948,8 @@
         </p:nvSpPr>
         <p:spPr>
           <a:xfrm>
-            <a:off x="7909560" y="1234440"/>
-            <a:ext cx="475488" cy="475488"/>
+            <a:off x="7498080" y="1170432"/>
+            <a:ext cx="420624" cy="420624"/>
           </a:xfrm>
           <a:prstGeom prst="rect">
             <a:avLst/>
@@ -2957,7 +2957,7 @@
           <a:solidFill>
             <a:srgbClr val="F6FAFE"/>
           </a:solidFill>
-          <a:ln w="12700">
+          <a:ln w="9525">
             <a:solidFill>
               <a:srgbClr val="CADCFC"/>
             </a:solidFill>
@@ -2973,16 +2973,16 @@
         </p:nvSpPr>
         <p:spPr>
           <a:xfrm>
-            <a:off x="5532120" y="1709928"/>
-            <a:ext cx="475488" cy="475488"/>
-          </a:xfrm>
-          <a:prstGeom prst="rect">
-            <a:avLst/>
-          </a:prstGeom>
-          <a:solidFill>
-            <a:srgbClr val="F6FAFE"/>
-          </a:solidFill>
-          <a:ln w="12700">
+            <a:off x="7918704" y="1170432"/>
+            <a:ext cx="420624" cy="420624"/>
+          </a:xfrm>
+          <a:prstGeom prst="rect">
+            <a:avLst/>
+          </a:prstGeom>
+          <a:solidFill>
+            <a:srgbClr val="E3F1E8"/>
+          </a:solidFill>
+          <a:ln w="9525">
             <a:solidFill>
               <a:srgbClr val="CADCFC"/>
             </a:solidFill>
@@ -2998,16 +2998,16 @@
         </p:nvSpPr>
         <p:spPr>
           <a:xfrm>
-            <a:off x="6007608" y="1709928"/>
-            <a:ext cx="475488" cy="475488"/>
-          </a:xfrm>
-          <a:prstGeom prst="rect">
-            <a:avLst/>
-          </a:prstGeom>
-          <a:solidFill>
-            <a:srgbClr val="F6FAFE"/>
-          </a:solidFill>
-          <a:ln w="12700">
+            <a:off x="8339328" y="1170432"/>
+            <a:ext cx="420624" cy="420624"/>
+          </a:xfrm>
+          <a:prstGeom prst="rect">
+            <a:avLst/>
+          </a:prstGeom>
+          <a:solidFill>
+            <a:srgbClr val="3A4750"/>
+          </a:solidFill>
+          <a:ln w="9525">
             <a:solidFill>
               <a:srgbClr val="CADCFC"/>
             </a:solidFill>
@@ -3023,8 +3023,8 @@
         </p:nvSpPr>
         <p:spPr>
           <a:xfrm>
-            <a:off x="6483096" y="1709928"/>
-            <a:ext cx="475488" cy="475488"/>
+            <a:off x="5394960" y="1591056"/>
+            <a:ext cx="420624" cy="420624"/>
           </a:xfrm>
           <a:prstGeom prst="rect">
             <a:avLst/>
@@ -3032,7 +3032,7 @@
           <a:solidFill>
             <a:srgbClr val="F6FAFE"/>
           </a:solidFill>
-          <a:ln w="12700">
+          <a:ln w="9525">
             <a:solidFill>
               <a:srgbClr val="CADCFC"/>
             </a:solidFill>
@@ -3048,8 +3048,8 @@
         </p:nvSpPr>
         <p:spPr>
           <a:xfrm>
-            <a:off x="6958584" y="1709928"/>
-            <a:ext cx="475488" cy="475488"/>
+            <a:off x="5815584" y="1591056"/>
+            <a:ext cx="420624" cy="420624"/>
           </a:xfrm>
           <a:prstGeom prst="rect">
             <a:avLst/>
@@ -3057,7 +3057,7 @@
           <a:solidFill>
             <a:srgbClr val="F6FAFE"/>
           </a:solidFill>
-          <a:ln w="12700">
+          <a:ln w="9525">
             <a:solidFill>
               <a:srgbClr val="CADCFC"/>
             </a:solidFill>
@@ -3073,16 +3073,16 @@
         </p:nvSpPr>
         <p:spPr>
           <a:xfrm>
-            <a:off x="7434072" y="1709928"/>
-            <a:ext cx="475488" cy="475488"/>
-          </a:xfrm>
-          <a:prstGeom prst="rect">
-            <a:avLst/>
-          </a:prstGeom>
-          <a:solidFill>
-            <a:srgbClr val="F6FAFE"/>
-          </a:solidFill>
-          <a:ln w="12700">
+            <a:off x="6236208" y="1591056"/>
+            <a:ext cx="420624" cy="420624"/>
+          </a:xfrm>
+          <a:prstGeom prst="rect">
+            <a:avLst/>
+          </a:prstGeom>
+          <a:solidFill>
+            <a:srgbClr val="3A4750"/>
+          </a:solidFill>
+          <a:ln w="9525">
             <a:solidFill>
               <a:srgbClr val="CADCFC"/>
             </a:solidFill>
@@ -3098,16 +3098,16 @@
         </p:nvSpPr>
         <p:spPr>
           <a:xfrm>
-            <a:off x="7909560" y="1709928"/>
-            <a:ext cx="475488" cy="475488"/>
-          </a:xfrm>
-          <a:prstGeom prst="rect">
-            <a:avLst/>
-          </a:prstGeom>
-          <a:solidFill>
-            <a:srgbClr val="F6FAFE"/>
-          </a:solidFill>
-          <a:ln w="12700">
+            <a:off x="6656832" y="1591056"/>
+            <a:ext cx="420624" cy="420624"/>
+          </a:xfrm>
+          <a:prstGeom prst="rect">
+            <a:avLst/>
+          </a:prstGeom>
+          <a:solidFill>
+            <a:srgbClr val="3A4750"/>
+          </a:solidFill>
+          <a:ln w="9525">
             <a:solidFill>
               <a:srgbClr val="CADCFC"/>
             </a:solidFill>
@@ -3123,8 +3123,8 @@
         </p:nvSpPr>
         <p:spPr>
           <a:xfrm>
-            <a:off x="5532120" y="2185416"/>
-            <a:ext cx="475488" cy="475488"/>
+            <a:off x="7077456" y="1591056"/>
+            <a:ext cx="420624" cy="420624"/>
           </a:xfrm>
           <a:prstGeom prst="rect">
             <a:avLst/>
@@ -3132,7 +3132,7 @@
           <a:solidFill>
             <a:srgbClr val="F6FAFE"/>
           </a:solidFill>
-          <a:ln w="12700">
+          <a:ln w="9525">
             <a:solidFill>
               <a:srgbClr val="CADCFC"/>
             </a:solidFill>
@@ -3148,8 +3148,8 @@
         </p:nvSpPr>
         <p:spPr>
           <a:xfrm>
-            <a:off x="6007608" y="2185416"/>
-            <a:ext cx="475488" cy="475488"/>
+            <a:off x="7498080" y="1591056"/>
+            <a:ext cx="420624" cy="420624"/>
           </a:xfrm>
           <a:prstGeom prst="rect">
             <a:avLst/>
@@ -3157,7 +3157,7 @@
           <a:solidFill>
             <a:srgbClr val="F6FAFE"/>
           </a:solidFill>
-          <a:ln w="12700">
+          <a:ln w="9525">
             <a:solidFill>
               <a:srgbClr val="CADCFC"/>
             </a:solidFill>
@@ -3173,16 +3173,16 @@
         </p:nvSpPr>
         <p:spPr>
           <a:xfrm>
-            <a:off x="6483096" y="2185416"/>
-            <a:ext cx="475488" cy="475488"/>
-          </a:xfrm>
-          <a:prstGeom prst="rect">
-            <a:avLst/>
-          </a:prstGeom>
-          <a:solidFill>
-            <a:srgbClr val="F6FAFE"/>
-          </a:solidFill>
-          <a:ln w="12700">
+            <a:off x="7918704" y="1591056"/>
+            <a:ext cx="420624" cy="420624"/>
+          </a:xfrm>
+          <a:prstGeom prst="rect">
+            <a:avLst/>
+          </a:prstGeom>
+          <a:solidFill>
+            <a:srgbClr val="E3F1E8"/>
+          </a:solidFill>
+          <a:ln w="9525">
             <a:solidFill>
               <a:srgbClr val="CADCFC"/>
             </a:solidFill>
@@ -3198,16 +3198,16 @@
         </p:nvSpPr>
         <p:spPr>
           <a:xfrm>
-            <a:off x="6958584" y="2185416"/>
-            <a:ext cx="475488" cy="475488"/>
-          </a:xfrm>
-          <a:prstGeom prst="rect">
-            <a:avLst/>
-          </a:prstGeom>
-          <a:solidFill>
-            <a:srgbClr val="F6FAFE"/>
-          </a:solidFill>
-          <a:ln w="12700">
+            <a:off x="8339328" y="1591056"/>
+            <a:ext cx="420624" cy="420624"/>
+          </a:xfrm>
+          <a:prstGeom prst="rect">
+            <a:avLst/>
+          </a:prstGeom>
+          <a:solidFill>
+            <a:srgbClr val="3A4750"/>
+          </a:solidFill>
+          <a:ln w="9525">
             <a:solidFill>
               <a:srgbClr val="CADCFC"/>
             </a:solidFill>
@@ -3223,8 +3223,8 @@
         </p:nvSpPr>
         <p:spPr>
           <a:xfrm>
-            <a:off x="7434072" y="2185416"/>
-            <a:ext cx="475488" cy="475488"/>
+            <a:off x="5394960" y="2011680"/>
+            <a:ext cx="420624" cy="420624"/>
           </a:xfrm>
           <a:prstGeom prst="rect">
             <a:avLst/>
@@ -3232,7 +3232,7 @@
           <a:solidFill>
             <a:srgbClr val="F6FAFE"/>
           </a:solidFill>
-          <a:ln w="12700">
+          <a:ln w="9525">
             <a:solidFill>
               <a:srgbClr val="CADCFC"/>
             </a:solidFill>
@@ -3248,8 +3248,8 @@
         </p:nvSpPr>
         <p:spPr>
           <a:xfrm>
-            <a:off x="7909560" y="2185416"/>
-            <a:ext cx="475488" cy="475488"/>
+            <a:off x="5815584" y="2011680"/>
+            <a:ext cx="420624" cy="420624"/>
           </a:xfrm>
           <a:prstGeom prst="rect">
             <a:avLst/>
@@ -3257,7 +3257,7 @@
           <a:solidFill>
             <a:srgbClr val="F6FAFE"/>
           </a:solidFill>
-          <a:ln w="12700">
+          <a:ln w="9525">
             <a:solidFill>
               <a:srgbClr val="CADCFC"/>
             </a:solidFill>
@@ -3273,8 +3273,8 @@
         </p:nvSpPr>
         <p:spPr>
           <a:xfrm>
-            <a:off x="5532120" y="2660904"/>
-            <a:ext cx="475488" cy="475488"/>
+            <a:off x="6236208" y="2011680"/>
+            <a:ext cx="420624" cy="420624"/>
           </a:xfrm>
           <a:prstGeom prst="rect">
             <a:avLst/>
@@ -3282,7 +3282,7 @@
           <a:solidFill>
             <a:srgbClr val="F6FAFE"/>
           </a:solidFill>
-          <a:ln w="12700">
+          <a:ln w="9525">
             <a:solidFill>
               <a:srgbClr val="CADCFC"/>
             </a:solidFill>
@@ -3298,8 +3298,8 @@
         </p:nvSpPr>
         <p:spPr>
           <a:xfrm>
-            <a:off x="6007608" y="2660904"/>
-            <a:ext cx="475488" cy="475488"/>
+            <a:off x="6656832" y="2011680"/>
+            <a:ext cx="420624" cy="420624"/>
           </a:xfrm>
           <a:prstGeom prst="rect">
             <a:avLst/>
@@ -3307,7 +3307,7 @@
           <a:solidFill>
             <a:srgbClr val="F6FAFE"/>
           </a:solidFill>
-          <a:ln w="12700">
+          <a:ln w="9525">
             <a:solidFill>
               <a:srgbClr val="CADCFC"/>
             </a:solidFill>
@@ -3323,16 +3323,16 @@
         </p:nvSpPr>
         <p:spPr>
           <a:xfrm>
-            <a:off x="6483096" y="2660904"/>
-            <a:ext cx="475488" cy="475488"/>
-          </a:xfrm>
-          <a:prstGeom prst="rect">
-            <a:avLst/>
-          </a:prstGeom>
-          <a:solidFill>
-            <a:srgbClr val="F6FAFE"/>
-          </a:solidFill>
-          <a:ln w="12700">
+            <a:off x="7077456" y="2011680"/>
+            <a:ext cx="420624" cy="420624"/>
+          </a:xfrm>
+          <a:prstGeom prst="rect">
+            <a:avLst/>
+          </a:prstGeom>
+          <a:solidFill>
+            <a:srgbClr val="3A4750"/>
+          </a:solidFill>
+          <a:ln w="9525">
             <a:solidFill>
               <a:srgbClr val="CADCFC"/>
             </a:solidFill>
@@ -3348,8 +3348,8 @@
         </p:nvSpPr>
         <p:spPr>
           <a:xfrm>
-            <a:off x="6958584" y="2660904"/>
-            <a:ext cx="475488" cy="475488"/>
+            <a:off x="7498080" y="2011680"/>
+            <a:ext cx="420624" cy="420624"/>
           </a:xfrm>
           <a:prstGeom prst="rect">
             <a:avLst/>
@@ -3357,7 +3357,7 @@
           <a:solidFill>
             <a:srgbClr val="F6FAFE"/>
           </a:solidFill>
-          <a:ln w="12700">
+          <a:ln w="9525">
             <a:solidFill>
               <a:srgbClr val="CADCFC"/>
             </a:solidFill>
@@ -3373,16 +3373,16 @@
         </p:nvSpPr>
         <p:spPr>
           <a:xfrm>
-            <a:off x="7434072" y="2660904"/>
-            <a:ext cx="475488" cy="475488"/>
-          </a:xfrm>
-          <a:prstGeom prst="rect">
-            <a:avLst/>
-          </a:prstGeom>
-          <a:solidFill>
-            <a:srgbClr val="F6FAFE"/>
-          </a:solidFill>
-          <a:ln w="12700">
+            <a:off x="7918704" y="2011680"/>
+            <a:ext cx="420624" cy="420624"/>
+          </a:xfrm>
+          <a:prstGeom prst="rect">
+            <a:avLst/>
+          </a:prstGeom>
+          <a:solidFill>
+            <a:srgbClr val="E3F1E8"/>
+          </a:solidFill>
+          <a:ln w="9525">
             <a:solidFill>
               <a:srgbClr val="CADCFC"/>
             </a:solidFill>
@@ -3398,16 +3398,16 @@
         </p:nvSpPr>
         <p:spPr>
           <a:xfrm>
-            <a:off x="7909560" y="2660904"/>
-            <a:ext cx="475488" cy="475488"/>
-          </a:xfrm>
-          <a:prstGeom prst="rect">
-            <a:avLst/>
-          </a:prstGeom>
-          <a:solidFill>
-            <a:srgbClr val="F6FAFE"/>
-          </a:solidFill>
-          <a:ln w="12700">
+            <a:off x="8339328" y="2011680"/>
+            <a:ext cx="420624" cy="420624"/>
+          </a:xfrm>
+          <a:prstGeom prst="rect">
+            <a:avLst/>
+          </a:prstGeom>
+          <a:solidFill>
+            <a:srgbClr val="3A4750"/>
+          </a:solidFill>
+          <a:ln w="9525">
             <a:solidFill>
               <a:srgbClr val="CADCFC"/>
             </a:solidFill>
@@ -3423,8 +3423,8 @@
         </p:nvSpPr>
         <p:spPr>
           <a:xfrm>
-            <a:off x="5532120" y="3136392"/>
-            <a:ext cx="475488" cy="475488"/>
+            <a:off x="5394960" y="2432304"/>
+            <a:ext cx="420624" cy="420624"/>
           </a:xfrm>
           <a:prstGeom prst="rect">
             <a:avLst/>
@@ -3432,7 +3432,7 @@
           <a:solidFill>
             <a:srgbClr val="F6FAFE"/>
           </a:solidFill>
-          <a:ln w="12700">
+          <a:ln w="9525">
             <a:solidFill>
               <a:srgbClr val="CADCFC"/>
             </a:solidFill>
@@ -3448,8 +3448,8 @@
         </p:nvSpPr>
         <p:spPr>
           <a:xfrm>
-            <a:off x="6007608" y="3136392"/>
-            <a:ext cx="475488" cy="475488"/>
+            <a:off x="5815584" y="2432304"/>
+            <a:ext cx="420624" cy="420624"/>
           </a:xfrm>
           <a:prstGeom prst="rect">
             <a:avLst/>
@@ -3457,7 +3457,7 @@
           <a:solidFill>
             <a:srgbClr val="F6FAFE"/>
           </a:solidFill>
-          <a:ln w="12700">
+          <a:ln w="9525">
             <a:solidFill>
               <a:srgbClr val="CADCFC"/>
             </a:solidFill>
@@ -3473,16 +3473,16 @@
         </p:nvSpPr>
         <p:spPr>
           <a:xfrm>
-            <a:off x="6483096" y="3136392"/>
-            <a:ext cx="475488" cy="475488"/>
-          </a:xfrm>
-          <a:prstGeom prst="rect">
-            <a:avLst/>
-          </a:prstGeom>
-          <a:solidFill>
-            <a:srgbClr val="F6FAFE"/>
-          </a:solidFill>
-          <a:ln w="12700">
+            <a:off x="6236208" y="2432304"/>
+            <a:ext cx="420624" cy="420624"/>
+          </a:xfrm>
+          <a:prstGeom prst="rect">
+            <a:avLst/>
+          </a:prstGeom>
+          <a:solidFill>
+            <a:srgbClr val="3A4750"/>
+          </a:solidFill>
+          <a:ln w="9525">
             <a:solidFill>
               <a:srgbClr val="CADCFC"/>
             </a:solidFill>
@@ -3498,16 +3498,16 @@
         </p:nvSpPr>
         <p:spPr>
           <a:xfrm>
-            <a:off x="6958584" y="3136392"/>
-            <a:ext cx="475488" cy="475488"/>
-          </a:xfrm>
-          <a:prstGeom prst="rect">
-            <a:avLst/>
-          </a:prstGeom>
-          <a:solidFill>
-            <a:srgbClr val="F6FAFE"/>
-          </a:solidFill>
-          <a:ln w="12700">
+            <a:off x="6656832" y="2432304"/>
+            <a:ext cx="420624" cy="420624"/>
+          </a:xfrm>
+          <a:prstGeom prst="rect">
+            <a:avLst/>
+          </a:prstGeom>
+          <a:solidFill>
+            <a:srgbClr val="3A4750"/>
+          </a:solidFill>
+          <a:ln w="9525">
             <a:solidFill>
               <a:srgbClr val="CADCFC"/>
             </a:solidFill>
@@ -3523,8 +3523,8 @@
         </p:nvSpPr>
         <p:spPr>
           <a:xfrm>
-            <a:off x="7434072" y="3136392"/>
-            <a:ext cx="475488" cy="475488"/>
+            <a:off x="7077456" y="2432304"/>
+            <a:ext cx="420624" cy="420624"/>
           </a:xfrm>
           <a:prstGeom prst="rect">
             <a:avLst/>
@@ -3532,7 +3532,7 @@
           <a:solidFill>
             <a:srgbClr val="F6FAFE"/>
           </a:solidFill>
-          <a:ln w="12700">
+          <a:ln w="9525">
             <a:solidFill>
               <a:srgbClr val="CADCFC"/>
             </a:solidFill>
@@ -3548,8 +3548,8 @@
         </p:nvSpPr>
         <p:spPr>
           <a:xfrm>
-            <a:off x="7909560" y="3136392"/>
-            <a:ext cx="475488" cy="475488"/>
+            <a:off x="7498080" y="2432304"/>
+            <a:ext cx="420624" cy="420624"/>
           </a:xfrm>
           <a:prstGeom prst="rect">
             <a:avLst/>
@@ -3557,7 +3557,7 @@
           <a:solidFill>
             <a:srgbClr val="F6FAFE"/>
           </a:solidFill>
-          <a:ln w="12700">
+          <a:ln w="9525">
             <a:solidFill>
               <a:srgbClr val="CADCFC"/>
             </a:solidFill>
@@ -3573,13 +3573,519 @@
         </p:nvSpPr>
         <p:spPr>
           <a:xfrm>
-            <a:off x="5559552" y="1261872"/>
+            <a:off x="7918704" y="2432304"/>
             <a:ext cx="420624" cy="420624"/>
           </a:xfrm>
           <a:prstGeom prst="rect">
             <a:avLst/>
           </a:prstGeom>
           <a:solidFill>
+            <a:srgbClr val="E3F1E8"/>
+          </a:solidFill>
+          <a:ln w="9525">
+            <a:solidFill>
+              <a:srgbClr val="CADCFC"/>
+            </a:solidFill>
+            <a:prstDash val="solid"/>
+          </a:ln>
+        </p:spPr>
+      </p:sp>
+      <p:sp>
+        <p:nvSpPr>
+          <p:cNvPr id="52" name="Shape 50"/>
+          <p:cNvSpPr/>
+          <p:nvPr/>
+        </p:nvSpPr>
+        <p:spPr>
+          <a:xfrm>
+            <a:off x="8339328" y="2432304"/>
+            <a:ext cx="420624" cy="420624"/>
+          </a:xfrm>
+          <a:prstGeom prst="rect">
+            <a:avLst/>
+          </a:prstGeom>
+          <a:solidFill>
+            <a:srgbClr val="3A4750"/>
+          </a:solidFill>
+          <a:ln w="9525">
+            <a:solidFill>
+              <a:srgbClr val="CADCFC"/>
+            </a:solidFill>
+            <a:prstDash val="solid"/>
+          </a:ln>
+        </p:spPr>
+      </p:sp>
+      <p:sp>
+        <p:nvSpPr>
+          <p:cNvPr id="53" name="Shape 51"/>
+          <p:cNvSpPr/>
+          <p:nvPr/>
+        </p:nvSpPr>
+        <p:spPr>
+          <a:xfrm>
+            <a:off x="5394960" y="2852928"/>
+            <a:ext cx="420624" cy="420624"/>
+          </a:xfrm>
+          <a:prstGeom prst="rect">
+            <a:avLst/>
+          </a:prstGeom>
+          <a:solidFill>
+            <a:srgbClr val="F6FAFE"/>
+          </a:solidFill>
+          <a:ln w="9525">
+            <a:solidFill>
+              <a:srgbClr val="CADCFC"/>
+            </a:solidFill>
+            <a:prstDash val="solid"/>
+          </a:ln>
+        </p:spPr>
+      </p:sp>
+      <p:sp>
+        <p:nvSpPr>
+          <p:cNvPr id="54" name="Shape 52"/>
+          <p:cNvSpPr/>
+          <p:nvPr/>
+        </p:nvSpPr>
+        <p:spPr>
+          <a:xfrm>
+            <a:off x="5815584" y="2852928"/>
+            <a:ext cx="420624" cy="420624"/>
+          </a:xfrm>
+          <a:prstGeom prst="rect">
+            <a:avLst/>
+          </a:prstGeom>
+          <a:solidFill>
+            <a:srgbClr val="F6FAFE"/>
+          </a:solidFill>
+          <a:ln w="9525">
+            <a:solidFill>
+              <a:srgbClr val="CADCFC"/>
+            </a:solidFill>
+            <a:prstDash val="solid"/>
+          </a:ln>
+        </p:spPr>
+      </p:sp>
+      <p:sp>
+        <p:nvSpPr>
+          <p:cNvPr id="55" name="Shape 53"/>
+          <p:cNvSpPr/>
+          <p:nvPr/>
+        </p:nvSpPr>
+        <p:spPr>
+          <a:xfrm>
+            <a:off x="6236208" y="2852928"/>
+            <a:ext cx="420624" cy="420624"/>
+          </a:xfrm>
+          <a:prstGeom prst="rect">
+            <a:avLst/>
+          </a:prstGeom>
+          <a:solidFill>
+            <a:srgbClr val="F6FAFE"/>
+          </a:solidFill>
+          <a:ln w="9525">
+            <a:solidFill>
+              <a:srgbClr val="CADCFC"/>
+            </a:solidFill>
+            <a:prstDash val="solid"/>
+          </a:ln>
+        </p:spPr>
+      </p:sp>
+      <p:sp>
+        <p:nvSpPr>
+          <p:cNvPr id="56" name="Shape 54"/>
+          <p:cNvSpPr/>
+          <p:nvPr/>
+        </p:nvSpPr>
+        <p:spPr>
+          <a:xfrm>
+            <a:off x="6656832" y="2852928"/>
+            <a:ext cx="420624" cy="420624"/>
+          </a:xfrm>
+          <a:prstGeom prst="rect">
+            <a:avLst/>
+          </a:prstGeom>
+          <a:solidFill>
+            <a:srgbClr val="F6FAFE"/>
+          </a:solidFill>
+          <a:ln w="9525">
+            <a:solidFill>
+              <a:srgbClr val="CADCFC"/>
+            </a:solidFill>
+            <a:prstDash val="solid"/>
+          </a:ln>
+        </p:spPr>
+      </p:sp>
+      <p:sp>
+        <p:nvSpPr>
+          <p:cNvPr id="57" name="Shape 55"/>
+          <p:cNvSpPr/>
+          <p:nvPr/>
+        </p:nvSpPr>
+        <p:spPr>
+          <a:xfrm>
+            <a:off x="7077456" y="2852928"/>
+            <a:ext cx="420624" cy="420624"/>
+          </a:xfrm>
+          <a:prstGeom prst="rect">
+            <a:avLst/>
+          </a:prstGeom>
+          <a:solidFill>
+            <a:srgbClr val="F6FAFE"/>
+          </a:solidFill>
+          <a:ln w="9525">
+            <a:solidFill>
+              <a:srgbClr val="CADCFC"/>
+            </a:solidFill>
+            <a:prstDash val="solid"/>
+          </a:ln>
+        </p:spPr>
+      </p:sp>
+      <p:sp>
+        <p:nvSpPr>
+          <p:cNvPr id="58" name="Shape 56"/>
+          <p:cNvSpPr/>
+          <p:nvPr/>
+        </p:nvSpPr>
+        <p:spPr>
+          <a:xfrm>
+            <a:off x="7498080" y="2852928"/>
+            <a:ext cx="420624" cy="420624"/>
+          </a:xfrm>
+          <a:prstGeom prst="rect">
+            <a:avLst/>
+          </a:prstGeom>
+          <a:solidFill>
+            <a:srgbClr val="F6FAFE"/>
+          </a:solidFill>
+          <a:ln w="9525">
+            <a:solidFill>
+              <a:srgbClr val="CADCFC"/>
+            </a:solidFill>
+            <a:prstDash val="solid"/>
+          </a:ln>
+        </p:spPr>
+      </p:sp>
+      <p:sp>
+        <p:nvSpPr>
+          <p:cNvPr id="59" name="Shape 57"/>
+          <p:cNvSpPr/>
+          <p:nvPr/>
+        </p:nvSpPr>
+        <p:spPr>
+          <a:xfrm>
+            <a:off x="7918704" y="2852928"/>
+            <a:ext cx="420624" cy="420624"/>
+          </a:xfrm>
+          <a:prstGeom prst="rect">
+            <a:avLst/>
+          </a:prstGeom>
+          <a:solidFill>
+            <a:srgbClr val="E3F1E8"/>
+          </a:solidFill>
+          <a:ln w="9525">
+            <a:solidFill>
+              <a:srgbClr val="CADCFC"/>
+            </a:solidFill>
+            <a:prstDash val="solid"/>
+          </a:ln>
+        </p:spPr>
+      </p:sp>
+      <p:sp>
+        <p:nvSpPr>
+          <p:cNvPr id="60" name="Shape 58"/>
+          <p:cNvSpPr/>
+          <p:nvPr/>
+        </p:nvSpPr>
+        <p:spPr>
+          <a:xfrm>
+            <a:off x="8339328" y="2852928"/>
+            <a:ext cx="420624" cy="420624"/>
+          </a:xfrm>
+          <a:prstGeom prst="rect">
+            <a:avLst/>
+          </a:prstGeom>
+          <a:solidFill>
+            <a:srgbClr val="3A4750"/>
+          </a:solidFill>
+          <a:ln w="9525">
+            <a:solidFill>
+              <a:srgbClr val="CADCFC"/>
+            </a:solidFill>
+            <a:prstDash val="solid"/>
+          </a:ln>
+        </p:spPr>
+      </p:sp>
+      <p:sp>
+        <p:nvSpPr>
+          <p:cNvPr id="61" name="Shape 59"/>
+          <p:cNvSpPr/>
+          <p:nvPr/>
+        </p:nvSpPr>
+        <p:spPr>
+          <a:xfrm>
+            <a:off x="5394960" y="3273552"/>
+            <a:ext cx="420624" cy="420624"/>
+          </a:xfrm>
+          <a:prstGeom prst="rect">
+            <a:avLst/>
+          </a:prstGeom>
+          <a:solidFill>
+            <a:srgbClr val="3A4750"/>
+          </a:solidFill>
+          <a:ln w="9525">
+            <a:solidFill>
+              <a:srgbClr val="CADCFC"/>
+            </a:solidFill>
+            <a:prstDash val="solid"/>
+          </a:ln>
+        </p:spPr>
+      </p:sp>
+      <p:sp>
+        <p:nvSpPr>
+          <p:cNvPr id="62" name="Shape 60"/>
+          <p:cNvSpPr/>
+          <p:nvPr/>
+        </p:nvSpPr>
+        <p:spPr>
+          <a:xfrm>
+            <a:off x="5815584" y="3273552"/>
+            <a:ext cx="420624" cy="420624"/>
+          </a:xfrm>
+          <a:prstGeom prst="rect">
+            <a:avLst/>
+          </a:prstGeom>
+          <a:solidFill>
+            <a:srgbClr val="3A4750"/>
+          </a:solidFill>
+          <a:ln w="9525">
+            <a:solidFill>
+              <a:srgbClr val="CADCFC"/>
+            </a:solidFill>
+            <a:prstDash val="solid"/>
+          </a:ln>
+        </p:spPr>
+      </p:sp>
+      <p:sp>
+        <p:nvSpPr>
+          <p:cNvPr id="63" name="Shape 61"/>
+          <p:cNvSpPr/>
+          <p:nvPr/>
+        </p:nvSpPr>
+        <p:spPr>
+          <a:xfrm>
+            <a:off x="6236208" y="3273552"/>
+            <a:ext cx="420624" cy="420624"/>
+          </a:xfrm>
+          <a:prstGeom prst="rect">
+            <a:avLst/>
+          </a:prstGeom>
+          <a:solidFill>
+            <a:srgbClr val="3A4750"/>
+          </a:solidFill>
+          <a:ln w="9525">
+            <a:solidFill>
+              <a:srgbClr val="CADCFC"/>
+            </a:solidFill>
+            <a:prstDash val="solid"/>
+          </a:ln>
+        </p:spPr>
+      </p:sp>
+      <p:sp>
+        <p:nvSpPr>
+          <p:cNvPr id="64" name="Shape 62"/>
+          <p:cNvSpPr/>
+          <p:nvPr/>
+        </p:nvSpPr>
+        <p:spPr>
+          <a:xfrm>
+            <a:off x="6656832" y="3273552"/>
+            <a:ext cx="420624" cy="420624"/>
+          </a:xfrm>
+          <a:prstGeom prst="rect">
+            <a:avLst/>
+          </a:prstGeom>
+          <a:solidFill>
+            <a:srgbClr val="3A4750"/>
+          </a:solidFill>
+          <a:ln w="9525">
+            <a:solidFill>
+              <a:srgbClr val="CADCFC"/>
+            </a:solidFill>
+            <a:prstDash val="solid"/>
+          </a:ln>
+        </p:spPr>
+      </p:sp>
+      <p:sp>
+        <p:nvSpPr>
+          <p:cNvPr id="65" name="Shape 63"/>
+          <p:cNvSpPr/>
+          <p:nvPr/>
+        </p:nvSpPr>
+        <p:spPr>
+          <a:xfrm>
+            <a:off x="7077456" y="3273552"/>
+            <a:ext cx="420624" cy="420624"/>
+          </a:xfrm>
+          <a:prstGeom prst="rect">
+            <a:avLst/>
+          </a:prstGeom>
+          <a:solidFill>
+            <a:srgbClr val="3A4750"/>
+          </a:solidFill>
+          <a:ln w="9525">
+            <a:solidFill>
+              <a:srgbClr val="CADCFC"/>
+            </a:solidFill>
+            <a:prstDash val="solid"/>
+          </a:ln>
+        </p:spPr>
+      </p:sp>
+      <p:sp>
+        <p:nvSpPr>
+          <p:cNvPr id="66" name="Shape 64"/>
+          <p:cNvSpPr/>
+          <p:nvPr/>
+        </p:nvSpPr>
+        <p:spPr>
+          <a:xfrm>
+            <a:off x="7498080" y="3273552"/>
+            <a:ext cx="420624" cy="420624"/>
+          </a:xfrm>
+          <a:prstGeom prst="rect">
+            <a:avLst/>
+          </a:prstGeom>
+          <a:solidFill>
+            <a:srgbClr val="3A4750"/>
+          </a:solidFill>
+          <a:ln w="9525">
+            <a:solidFill>
+              <a:srgbClr val="CADCFC"/>
+            </a:solidFill>
+            <a:prstDash val="solid"/>
+          </a:ln>
+        </p:spPr>
+      </p:sp>
+      <p:sp>
+        <p:nvSpPr>
+          <p:cNvPr id="67" name="Shape 65"/>
+          <p:cNvSpPr/>
+          <p:nvPr/>
+        </p:nvSpPr>
+        <p:spPr>
+          <a:xfrm>
+            <a:off x="7918704" y="3273552"/>
+            <a:ext cx="420624" cy="420624"/>
+          </a:xfrm>
+          <a:prstGeom prst="rect">
+            <a:avLst/>
+          </a:prstGeom>
+          <a:solidFill>
+            <a:srgbClr val="3A4750"/>
+          </a:solidFill>
+          <a:ln w="9525">
+            <a:solidFill>
+              <a:srgbClr val="CADCFC"/>
+            </a:solidFill>
+            <a:prstDash val="solid"/>
+          </a:ln>
+        </p:spPr>
+      </p:sp>
+      <p:sp>
+        <p:nvSpPr>
+          <p:cNvPr id="68" name="Shape 66"/>
+          <p:cNvSpPr/>
+          <p:nvPr/>
+        </p:nvSpPr>
+        <p:spPr>
+          <a:xfrm>
+            <a:off x="8339328" y="3273552"/>
+            <a:ext cx="420624" cy="420624"/>
+          </a:xfrm>
+          <a:prstGeom prst="rect">
+            <a:avLst/>
+          </a:prstGeom>
+          <a:solidFill>
+            <a:srgbClr val="3A4750"/>
+          </a:solidFill>
+          <a:ln w="9525">
+            <a:solidFill>
+              <a:srgbClr val="CADCFC"/>
+            </a:solidFill>
+            <a:prstDash val="solid"/>
+          </a:ln>
+        </p:spPr>
+      </p:sp>
+      <p:sp>
+        <p:nvSpPr>
+          <p:cNvPr id="69" name="Text 67"/>
+          <p:cNvSpPr/>
+          <p:nvPr/>
+        </p:nvSpPr>
+        <p:spPr>
+          <a:xfrm>
+            <a:off x="7918704" y="1170432"/>
+            <a:ext cx="420624" cy="420624"/>
+          </a:xfrm>
+          <a:prstGeom prst="rect">
+            <a:avLst/>
+          </a:prstGeom>
+          <a:noFill/>
+          <a:ln/>
+        </p:spPr>
+        <p:txBody>
+          <a:bodyPr wrap="square" lIns="0" tIns="0" rIns="0" bIns="0" rtlCol="0" anchor="ctr"/>
+          <a:lstStyle/>
+          <a:p>
+            <a:pPr algn="ctr" indent="0" marL="0">
+              <a:buNone/>
+            </a:pPr>
+            <a:r>
+              <a:rPr lang="en-US" sz="650" i="1" dirty="0">
+                <a:solidFill>
+                  <a:srgbClr val="2C8C5A"/>
+                </a:solidFill>
+                <a:latin typeface="Calibri" pitchFamily="34" charset="0"/>
+                <a:ea typeface="Calibri" pitchFamily="34" charset="-122"/>
+                <a:cs typeface="Calibri" pitchFamily="34" charset="-120"/>
+              </a:rPr>
+              <a:t>free</a:t>
+            </a:r>
+            <a:endParaRPr lang="en-US" sz="650" dirty="0"/>
+          </a:p>
+          <a:p>
+            <a:pPr algn="ctr" indent="0" marL="0">
+              <a:buNone/>
+            </a:pPr>
+            <a:r>
+              <a:rPr lang="en-US" sz="650" i="1" dirty="0">
+                <a:solidFill>
+                  <a:srgbClr val="2C8C5A"/>
+                </a:solidFill>
+                <a:latin typeface="Calibri" pitchFamily="34" charset="0"/>
+                <a:ea typeface="Calibri" pitchFamily="34" charset="-122"/>
+                <a:cs typeface="Calibri" pitchFamily="34" charset="-120"/>
+              </a:rPr>
+              <a:t>passage</a:t>
+            </a:r>
+            <a:endParaRPr lang="en-US" sz="650" dirty="0"/>
+          </a:p>
+        </p:txBody>
+      </p:sp>
+      <p:sp>
+        <p:nvSpPr>
+          <p:cNvPr id="70" name="Shape 68"/>
+          <p:cNvSpPr/>
+          <p:nvPr/>
+        </p:nvSpPr>
+        <p:spPr>
+          <a:xfrm>
+            <a:off x="5422392" y="1197864"/>
+            <a:ext cx="365760" cy="365760"/>
+          </a:xfrm>
+          <a:prstGeom prst="rect">
+            <a:avLst/>
+          </a:prstGeom>
+          <a:solidFill>
             <a:srgbClr val="21295C"/>
           </a:solidFill>
           <a:ln/>
@@ -3587,14 +4093,14 @@
       </p:sp>
       <p:sp>
         <p:nvSpPr>
-          <p:cNvPr id="52" name="Text 50"/>
-          <p:cNvSpPr/>
-          <p:nvPr/>
-        </p:nvSpPr>
-        <p:spPr>
-          <a:xfrm>
-            <a:off x="5532120" y="1234440"/>
-            <a:ext cx="475488" cy="475488"/>
+          <p:cNvPr id="71" name="Text 69"/>
+          <p:cNvSpPr/>
+          <p:nvPr/>
+        </p:nvSpPr>
+        <p:spPr>
+          <a:xfrm>
+            <a:off x="5394960" y="1170432"/>
+            <a:ext cx="420624" cy="420624"/>
           </a:xfrm>
           <a:prstGeom prst="rect">
             <a:avLst/>
@@ -3610,7 +4116,7 @@
               <a:buNone/>
             </a:pPr>
             <a:r>
-              <a:rPr lang="en-US" sz="1000" b="1" dirty="0">
+              <a:rPr lang="en-US" sz="750" b="1" dirty="0">
                 <a:solidFill>
                   <a:srgbClr val="FFFFFF"/>
                 </a:solidFill>
@@ -3620,44 +4126,44 @@
               </a:rPr>
               <a:t>HOME</a:t>
             </a:r>
-            <a:endParaRPr lang="en-US" sz="1000" dirty="0"/>
-          </a:p>
-        </p:txBody>
-      </p:sp>
-      <p:sp>
-        <p:nvSpPr>
-          <p:cNvPr id="53" name="Shape 51"/>
-          <p:cNvSpPr/>
-          <p:nvPr/>
-        </p:nvSpPr>
-        <p:spPr>
-          <a:xfrm>
-            <a:off x="5559552" y="3163824"/>
+            <a:endParaRPr lang="en-US" sz="750" dirty="0"/>
+          </a:p>
+        </p:txBody>
+      </p:sp>
+      <p:sp>
+        <p:nvSpPr>
+          <p:cNvPr id="72" name="Shape 70"/>
+          <p:cNvSpPr/>
+          <p:nvPr/>
+        </p:nvSpPr>
+        <p:spPr>
+          <a:xfrm>
+            <a:off x="5422392" y="2880360"/>
+            <a:ext cx="365760" cy="365760"/>
+          </a:xfrm>
+          <a:prstGeom prst="rect">
+            <a:avLst/>
+          </a:prstGeom>
+          <a:solidFill>
+            <a:srgbClr val="E8893D"/>
+          </a:solidFill>
+          <a:ln/>
+        </p:spPr>
+      </p:sp>
+      <p:sp>
+        <p:nvSpPr>
+          <p:cNvPr id="73" name="Text 71"/>
+          <p:cNvSpPr/>
+          <p:nvPr/>
+        </p:nvSpPr>
+        <p:spPr>
+          <a:xfrm>
+            <a:off x="5394960" y="2852928"/>
             <a:ext cx="420624" cy="420624"/>
           </a:xfrm>
           <a:prstGeom prst="rect">
             <a:avLst/>
           </a:prstGeom>
-          <a:solidFill>
-            <a:srgbClr val="E8893D"/>
-          </a:solidFill>
-          <a:ln/>
-        </p:spPr>
-      </p:sp>
-      <p:sp>
-        <p:nvSpPr>
-          <p:cNvPr id="54" name="Text 52"/>
-          <p:cNvSpPr/>
-          <p:nvPr/>
-        </p:nvSpPr>
-        <p:spPr>
-          <a:xfrm>
-            <a:off x="5532120" y="3136392"/>
-            <a:ext cx="475488" cy="475488"/>
-          </a:xfrm>
-          <a:prstGeom prst="rect">
-            <a:avLst/>
-          </a:prstGeom>
           <a:noFill/>
           <a:ln/>
         </p:spPr>
@@ -3669,7 +4175,7 @@
               <a:buNone/>
             </a:pPr>
             <a:r>
-              <a:rPr lang="en-US" sz="1000" b="1" dirty="0">
+              <a:rPr lang="en-US" sz="900" b="1" dirty="0">
                 <a:solidFill>
                   <a:srgbClr val="FFFFFF"/>
                 </a:solidFill>
@@ -3679,44 +4185,44 @@
               </a:rPr>
               <a:t>I/O</a:t>
             </a:r>
-            <a:endParaRPr lang="en-US" sz="1000" dirty="0"/>
-          </a:p>
-        </p:txBody>
-      </p:sp>
-      <p:sp>
-        <p:nvSpPr>
-          <p:cNvPr id="55" name="Shape 53"/>
-          <p:cNvSpPr/>
-          <p:nvPr/>
-        </p:nvSpPr>
-        <p:spPr>
-          <a:xfrm>
-            <a:off x="6035040" y="1737360"/>
+            <a:endParaRPr lang="en-US" sz="900" dirty="0"/>
+          </a:p>
+        </p:txBody>
+      </p:sp>
+      <p:sp>
+        <p:nvSpPr>
+          <p:cNvPr id="74" name="Shape 72"/>
+          <p:cNvSpPr/>
+          <p:nvPr/>
+        </p:nvSpPr>
+        <p:spPr>
+          <a:xfrm>
+            <a:off x="5843016" y="1618488"/>
+            <a:ext cx="365760" cy="365760"/>
+          </a:xfrm>
+          <a:prstGeom prst="rect">
+            <a:avLst/>
+          </a:prstGeom>
+          <a:solidFill>
+            <a:srgbClr val="1C7293"/>
+          </a:solidFill>
+          <a:ln/>
+        </p:spPr>
+      </p:sp>
+      <p:sp>
+        <p:nvSpPr>
+          <p:cNvPr id="75" name="Text 73"/>
+          <p:cNvSpPr/>
+          <p:nvPr/>
+        </p:nvSpPr>
+        <p:spPr>
+          <a:xfrm>
+            <a:off x="5815584" y="1591056"/>
             <a:ext cx="420624" cy="420624"/>
           </a:xfrm>
           <a:prstGeom prst="rect">
             <a:avLst/>
           </a:prstGeom>
-          <a:solidFill>
-            <a:srgbClr val="1C7293"/>
-          </a:solidFill>
-          <a:ln/>
-        </p:spPr>
-      </p:sp>
-      <p:sp>
-        <p:nvSpPr>
-          <p:cNvPr id="56" name="Text 54"/>
-          <p:cNvSpPr/>
-          <p:nvPr/>
-        </p:nvSpPr>
-        <p:spPr>
-          <a:xfrm>
-            <a:off x="6007608" y="1709928"/>
-            <a:ext cx="475488" cy="475488"/>
-          </a:xfrm>
-          <a:prstGeom prst="rect">
-            <a:avLst/>
-          </a:prstGeom>
           <a:noFill/>
           <a:ln/>
         </p:spPr>
@@ -3728,7 +4234,7 @@
               <a:buNone/>
             </a:pPr>
             <a:r>
-              <a:rPr lang="en-US" sz="1000" b="1" dirty="0">
+              <a:rPr lang="en-US" sz="900" b="1" dirty="0">
                 <a:solidFill>
                   <a:srgbClr val="FFFFFF"/>
                 </a:solidFill>
@@ -3738,44 +4244,44 @@
               </a:rPr>
               <a:t>S1</a:t>
             </a:r>
-            <a:endParaRPr lang="en-US" sz="1000" dirty="0"/>
-          </a:p>
-        </p:txBody>
-      </p:sp>
-      <p:sp>
-        <p:nvSpPr>
-          <p:cNvPr id="57" name="Shape 55"/>
-          <p:cNvSpPr/>
-          <p:nvPr/>
-        </p:nvSpPr>
-        <p:spPr>
-          <a:xfrm>
-            <a:off x="7461504" y="1737360"/>
+            <a:endParaRPr lang="en-US" sz="900" dirty="0"/>
+          </a:p>
+        </p:txBody>
+      </p:sp>
+      <p:sp>
+        <p:nvSpPr>
+          <p:cNvPr id="76" name="Shape 74"/>
+          <p:cNvSpPr/>
+          <p:nvPr/>
+        </p:nvSpPr>
+        <p:spPr>
+          <a:xfrm>
+            <a:off x="7104888" y="1618488"/>
+            <a:ext cx="365760" cy="365760"/>
+          </a:xfrm>
+          <a:prstGeom prst="rect">
+            <a:avLst/>
+          </a:prstGeom>
+          <a:solidFill>
+            <a:srgbClr val="1C7293"/>
+          </a:solidFill>
+          <a:ln/>
+        </p:spPr>
+      </p:sp>
+      <p:sp>
+        <p:nvSpPr>
+          <p:cNvPr id="77" name="Text 75"/>
+          <p:cNvSpPr/>
+          <p:nvPr/>
+        </p:nvSpPr>
+        <p:spPr>
+          <a:xfrm>
+            <a:off x="7077456" y="1591056"/>
             <a:ext cx="420624" cy="420624"/>
           </a:xfrm>
           <a:prstGeom prst="rect">
             <a:avLst/>
           </a:prstGeom>
-          <a:solidFill>
-            <a:srgbClr val="1C7293"/>
-          </a:solidFill>
-          <a:ln/>
-        </p:spPr>
-      </p:sp>
-      <p:sp>
-        <p:nvSpPr>
-          <p:cNvPr id="58" name="Text 56"/>
-          <p:cNvSpPr/>
-          <p:nvPr/>
-        </p:nvSpPr>
-        <p:spPr>
-          <a:xfrm>
-            <a:off x="7434072" y="1709928"/>
-            <a:ext cx="475488" cy="475488"/>
-          </a:xfrm>
-          <a:prstGeom prst="rect">
-            <a:avLst/>
-          </a:prstGeom>
           <a:noFill/>
           <a:ln/>
         </p:spPr>
@@ -3787,7 +4293,7 @@
               <a:buNone/>
             </a:pPr>
             <a:r>
-              <a:rPr lang="en-US" sz="1000" b="1" dirty="0">
+              <a:rPr lang="en-US" sz="900" b="1" dirty="0">
                 <a:solidFill>
                   <a:srgbClr val="FFFFFF"/>
                 </a:solidFill>
@@ -3797,44 +4303,44 @@
               </a:rPr>
               <a:t>S2</a:t>
             </a:r>
-            <a:endParaRPr lang="en-US" sz="1000" dirty="0"/>
-          </a:p>
-        </p:txBody>
-      </p:sp>
-      <p:sp>
-        <p:nvSpPr>
-          <p:cNvPr id="59" name="Shape 57"/>
-          <p:cNvSpPr/>
-          <p:nvPr/>
-        </p:nvSpPr>
-        <p:spPr>
-          <a:xfrm>
-            <a:off x="6035040" y="2688336"/>
+            <a:endParaRPr lang="en-US" sz="900" dirty="0"/>
+          </a:p>
+        </p:txBody>
+      </p:sp>
+      <p:sp>
+        <p:nvSpPr>
+          <p:cNvPr id="78" name="Shape 76"/>
+          <p:cNvSpPr/>
+          <p:nvPr/>
+        </p:nvSpPr>
+        <p:spPr>
+          <a:xfrm>
+            <a:off x="5843016" y="2459736"/>
+            <a:ext cx="365760" cy="365760"/>
+          </a:xfrm>
+          <a:prstGeom prst="rect">
+            <a:avLst/>
+          </a:prstGeom>
+          <a:solidFill>
+            <a:srgbClr val="1C7293"/>
+          </a:solidFill>
+          <a:ln/>
+        </p:spPr>
+      </p:sp>
+      <p:sp>
+        <p:nvSpPr>
+          <p:cNvPr id="79" name="Text 77"/>
+          <p:cNvSpPr/>
+          <p:nvPr/>
+        </p:nvSpPr>
+        <p:spPr>
+          <a:xfrm>
+            <a:off x="5815584" y="2432304"/>
             <a:ext cx="420624" cy="420624"/>
           </a:xfrm>
           <a:prstGeom prst="rect">
             <a:avLst/>
           </a:prstGeom>
-          <a:solidFill>
-            <a:srgbClr val="1C7293"/>
-          </a:solidFill>
-          <a:ln/>
-        </p:spPr>
-      </p:sp>
-      <p:sp>
-        <p:nvSpPr>
-          <p:cNvPr id="60" name="Text 58"/>
-          <p:cNvSpPr/>
-          <p:nvPr/>
-        </p:nvSpPr>
-        <p:spPr>
-          <a:xfrm>
-            <a:off x="6007608" y="2660904"/>
-            <a:ext cx="475488" cy="475488"/>
-          </a:xfrm>
-          <a:prstGeom prst="rect">
-            <a:avLst/>
-          </a:prstGeom>
           <a:noFill/>
           <a:ln/>
         </p:spPr>
@@ -3846,7 +4352,7 @@
               <a:buNone/>
             </a:pPr>
             <a:r>
-              <a:rPr lang="en-US" sz="1000" b="1" dirty="0">
+              <a:rPr lang="en-US" sz="900" b="1" dirty="0">
                 <a:solidFill>
                   <a:srgbClr val="FFFFFF"/>
                 </a:solidFill>
@@ -3856,44 +4362,44 @@
               </a:rPr>
               <a:t>S3</a:t>
             </a:r>
-            <a:endParaRPr lang="en-US" sz="1000" dirty="0"/>
-          </a:p>
-        </p:txBody>
-      </p:sp>
-      <p:sp>
-        <p:nvSpPr>
-          <p:cNvPr id="61" name="Shape 59"/>
-          <p:cNvSpPr/>
-          <p:nvPr/>
-        </p:nvSpPr>
-        <p:spPr>
-          <a:xfrm>
-            <a:off x="7461504" y="2688336"/>
+            <a:endParaRPr lang="en-US" sz="900" dirty="0"/>
+          </a:p>
+        </p:txBody>
+      </p:sp>
+      <p:sp>
+        <p:nvSpPr>
+          <p:cNvPr id="80" name="Shape 78"/>
+          <p:cNvSpPr/>
+          <p:nvPr/>
+        </p:nvSpPr>
+        <p:spPr>
+          <a:xfrm>
+            <a:off x="7104888" y="2459736"/>
+            <a:ext cx="365760" cy="365760"/>
+          </a:xfrm>
+          <a:prstGeom prst="rect">
+            <a:avLst/>
+          </a:prstGeom>
+          <a:solidFill>
+            <a:srgbClr val="1C7293"/>
+          </a:solidFill>
+          <a:ln/>
+        </p:spPr>
+      </p:sp>
+      <p:sp>
+        <p:nvSpPr>
+          <p:cNvPr id="81" name="Text 79"/>
+          <p:cNvSpPr/>
+          <p:nvPr/>
+        </p:nvSpPr>
+        <p:spPr>
+          <a:xfrm>
+            <a:off x="7077456" y="2432304"/>
             <a:ext cx="420624" cy="420624"/>
           </a:xfrm>
           <a:prstGeom prst="rect">
             <a:avLst/>
           </a:prstGeom>
-          <a:solidFill>
-            <a:srgbClr val="1C7293"/>
-          </a:solidFill>
-          <a:ln/>
-        </p:spPr>
-      </p:sp>
-      <p:sp>
-        <p:nvSpPr>
-          <p:cNvPr id="62" name="Text 60"/>
-          <p:cNvSpPr/>
-          <p:nvPr/>
-        </p:nvSpPr>
-        <p:spPr>
-          <a:xfrm>
-            <a:off x="7434072" y="2660904"/>
-            <a:ext cx="475488" cy="475488"/>
-          </a:xfrm>
-          <a:prstGeom prst="rect">
-            <a:avLst/>
-          </a:prstGeom>
           <a:noFill/>
           <a:ln/>
         </p:spPr>
@@ -3905,7 +4411,7 @@
               <a:buNone/>
             </a:pPr>
             <a:r>
-              <a:rPr lang="en-US" sz="1000" b="1" dirty="0">
+              <a:rPr lang="en-US" sz="900" b="1" dirty="0">
                 <a:solidFill>
                   <a:srgbClr val="FFFFFF"/>
                 </a:solidFill>
@@ -3915,44 +4421,44 @@
               </a:rPr>
               <a:t>S4</a:t>
             </a:r>
-            <a:endParaRPr lang="en-US" sz="1000" dirty="0"/>
-          </a:p>
-        </p:txBody>
-      </p:sp>
-      <p:sp>
-        <p:nvSpPr>
-          <p:cNvPr id="63" name="Shape 61"/>
-          <p:cNvSpPr/>
-          <p:nvPr/>
-        </p:nvSpPr>
-        <p:spPr>
-          <a:xfrm>
-            <a:off x="7936992" y="2212848"/>
+            <a:endParaRPr lang="en-US" sz="900" dirty="0"/>
+          </a:p>
+        </p:txBody>
+      </p:sp>
+      <p:sp>
+        <p:nvSpPr>
+          <p:cNvPr id="82" name="Shape 80"/>
+          <p:cNvSpPr/>
+          <p:nvPr/>
+        </p:nvSpPr>
+        <p:spPr>
+          <a:xfrm>
+            <a:off x="7525512" y="2039112"/>
+            <a:ext cx="365760" cy="365760"/>
+          </a:xfrm>
+          <a:prstGeom prst="rect">
+            <a:avLst/>
+          </a:prstGeom>
+          <a:solidFill>
+            <a:srgbClr val="2C8C5A"/>
+          </a:solidFill>
+          <a:ln/>
+        </p:spPr>
+      </p:sp>
+      <p:sp>
+        <p:nvSpPr>
+          <p:cNvPr id="83" name="Text 81"/>
+          <p:cNvSpPr/>
+          <p:nvPr/>
+        </p:nvSpPr>
+        <p:spPr>
+          <a:xfrm>
+            <a:off x="7498080" y="2011680"/>
             <a:ext cx="420624" cy="420624"/>
           </a:xfrm>
           <a:prstGeom prst="rect">
             <a:avLst/>
           </a:prstGeom>
-          <a:solidFill>
-            <a:srgbClr val="2C8C5A"/>
-          </a:solidFill>
-          <a:ln/>
-        </p:spPr>
-      </p:sp>
-      <p:sp>
-        <p:nvSpPr>
-          <p:cNvPr id="64" name="Text 62"/>
-          <p:cNvSpPr/>
-          <p:nvPr/>
-        </p:nvSpPr>
-        <p:spPr>
-          <a:xfrm>
-            <a:off x="7909560" y="2185416"/>
-            <a:ext cx="475488" cy="475488"/>
-          </a:xfrm>
-          <a:prstGeom prst="rect">
-            <a:avLst/>
-          </a:prstGeom>
           <a:noFill/>
           <a:ln/>
         </p:spPr>
@@ -3964,7 +4470,7 @@
               <a:buNone/>
             </a:pPr>
             <a:r>
-              <a:rPr lang="en-US" sz="1000" b="1" dirty="0">
+              <a:rPr lang="en-US" sz="900" b="1" dirty="0">
                 <a:solidFill>
                   <a:srgbClr val="FFFFFF"/>
                 </a:solidFill>
@@ -3974,20 +4480,20 @@
               </a:rPr>
               <a:t>S5</a:t>
             </a:r>
-            <a:endParaRPr lang="en-US" sz="1000" dirty="0"/>
-          </a:p>
-        </p:txBody>
-      </p:sp>
-      <p:sp>
-        <p:nvSpPr>
-          <p:cNvPr id="65" name="Text 63"/>
-          <p:cNvSpPr/>
-          <p:nvPr/>
-        </p:nvSpPr>
-        <p:spPr>
-          <a:xfrm>
-            <a:off x="5440680" y="3666744"/>
-            <a:ext cx="3566160" cy="274320"/>
+            <a:endParaRPr lang="en-US" sz="900" dirty="0"/>
+          </a:p>
+        </p:txBody>
+      </p:sp>
+      <p:sp>
+        <p:nvSpPr>
+          <p:cNvPr id="84" name="Text 82"/>
+          <p:cNvSpPr/>
+          <p:nvPr/>
+        </p:nvSpPr>
+        <p:spPr>
+          <a:xfrm>
+            <a:off x="5349240" y="3739896"/>
+            <a:ext cx="3547872" cy="365760"/>
           </a:xfrm>
           <a:prstGeom prst="rect">
             <a:avLst/>
@@ -4003,7 +4509,7 @@
               <a:buNone/>
             </a:pPr>
             <a:r>
-              <a:rPr lang="en-US" sz="1000" dirty="0">
+              <a:rPr lang="en-US" sz="850" dirty="0">
                 <a:solidFill>
                   <a:srgbClr val="5A6B7B"/>
                 </a:solidFill>
@@ -4011,15 +4517,15 @@
                 <a:ea typeface="Calibri" pitchFamily="34" charset="-122"/>
                 <a:cs typeface="Calibri" pitchFamily="34" charset="-120"/>
               </a:rPr>
-              <a:t>positions from the customer's map  |  S1..S4 = load slots, S5 = marking area</a:t>
-            </a:r>
-            <a:endParaRPr lang="en-US" sz="1000" dirty="0"/>
-          </a:p>
-        </p:txBody>
-      </p:sp>
-      <p:sp>
-        <p:nvSpPr>
-          <p:cNvPr id="66" name="Text 64"/>
+              <a:t>S1..S4 = load slots · S5 = marking · grey = obstacles/wall · green = free passage column</a:t>
+            </a:r>
+            <a:endParaRPr lang="en-US" sz="850" dirty="0"/>
+          </a:p>
+        </p:txBody>
+      </p:sp>
+      <p:sp>
+        <p:nvSpPr>
+          <p:cNvPr id="85" name="Text 83"/>
           <p:cNvSpPr/>
           <p:nvPr/>
         </p:nvSpPr>
@@ -4058,7 +4564,7 @@
       </p:sp>
       <p:sp>
         <p:nvSpPr>
-          <p:cNvPr id="67" name="Text 65"/>
+          <p:cNvPr id="86" name="Text 84"/>
           <p:cNvSpPr/>
           <p:nvPr/>
         </p:nvSpPr>
@@ -5003,7 +5509,7 @@
                 <a:ea typeface="Calibri" pitchFamily="34" charset="-122"/>
                 <a:cs typeface="Calibri" pitchFamily="34" charset="-120"/>
               </a:rPr>
-              <a:t>Sprint3_v1 + final system (28 PASS) + slides</a:t>
+              <a:t>Sprint3_v1 + final system (29 PASS) + slides</a:t>
             </a:r>
             <a:endParaRPr lang="en-US" sz="1050" dirty="0"/>
           </a:p>
@@ -10038,7 +10544,7 @@
                 <a:ea typeface="Calibri" pitchFamily="34" charset="-122"/>
                 <a:cs typeface="Calibri" pitchFamily="34" charset="-120"/>
               </a:rPr>
-              <a:t>Unit: TestHold 28 PASS, 0 FAIL  |  build: SUCCESS</a:t>
+              <a:t>Unit: TestHold 29 PASS, 0 FAIL  |  build: SUCCESS</a:t>
             </a:r>
             <a:endParaRPr lang="en-US" sz="1150" dirty="0"/>
           </a:p>
@@ -11122,7 +11628,7 @@
                 <a:ea typeface="Calibri" pitchFamily="34" charset="-122"/>
                 <a:cs typeface="Calibri" pitchFamily="34" charset="-120"/>
               </a:rPr>
-              <a:t>TestHold 16/20/28 PASS; end-to-end demo; automated TP1 with the tester actor</a:t>
+              <a:t>TestHold 16/20/29 PASS; end-to-end demo; automated TP1 with the tester actor</a:t>
             </a:r>
             <a:endParaRPr lang="en-US" sz="1400" dirty="0"/>
           </a:p>

</xml_diff>